<commit_message>
Update the French recap (docx, pptx): 579 checks, KYC four-eyes fix
Ten suites instead of eight (KYC approval, mandatory staff 2FA), three
fixes found by the tests instead of two, thirteen deliberate faults all
detected, and the mandatory 2FA no longer listed as untested. Pending
decisions gain keeping at least one independent KYC approver.

Co-Authored-By: Claude Opus 5.5 <noreply@anthropic.com>
Claude-Session: https://claude.ai/code/session_01ALCBMQrSwdEMnX9x1hQAFX
</commit_message>
<xml_diff>
--- a/outputs/recap/MIPS-recapitulatif.pptx
+++ b/outputs/recap/MIPS-recapitulatif.pptx
@@ -117,31 +117,31 @@
   <p:extLst>
     <p:ext uri="{521415D9-36F7-43E2-AB2F-B90AF26B5E84}">
       <p14:sectionLst xmlns:p14="http://schemas.microsoft.com/office/powerpoint/2010/main">
-        <p14:section name="Introduction" id="{ece87b05-b02d-5ae1-b8af-44a67482a9ee}">
+        <p14:section name="Introduction" id="{3d84282c-dd2e-e9be-fce3-e9d442f89700}">
           <p14:sldIdLst>
             <p14:sldId id="256"/>
             <p14:sldId id="257"/>
           </p14:sldIdLst>
         </p14:section>
-        <p14:section name="La plateforme" id="{985fdb88-eae9-439e-f75a-0816f97f723b}">
+        <p14:section name="La plateforme" id="{efb57f8e-6cc1-8ff7-3425-58634588c188}">
           <p14:sldIdLst>
             <p14:sldId id="258"/>
             <p14:sldId id="259"/>
             <p14:sldId id="260"/>
           </p14:sldIdLst>
         </p14:section>
-        <p14:section name="Fonds et BoM" id="{952aecd4-db84-2a36-9935-68b0dd1ffdd8}">
+        <p14:section name="Fonds et BoM" id="{c1743b85-26b9-d5be-33fa-3179219594b7}">
           <p14:sldIdLst>
             <p14:sldId id="261"/>
             <p14:sldId id="262"/>
           </p14:sldIdLst>
         </p14:section>
-        <p14:section name="Qualité" id="{7e17528f-4448-9893-0aca-bacb74271b9e}">
+        <p14:section name="Qualité" id="{1e843aba-b6d4-83a7-4911-0cb724480f3c}">
           <p14:sldIdLst>
             <p14:sldId id="263"/>
           </p14:sldIdLst>
         </p14:section>
-        <p14:section name="Suite" id="{94b78ed5-7f83-e59d-1ddc-cfd43b642064}">
+        <p14:section name="Suite" id="{4c63805f-e60b-f9da-d56f-b0b9b6b880cf}">
           <p14:sldIdLst>
             <p14:sldId id="264"/>
             <p14:sldId id="265"/>
@@ -816,7 +816,7 @@
           <a:p>
             <a:r>
               <a:rPr lang="en-US" dirty="0"/>
-              <a:t>Trois messages : ce qui est construit, ce que ça prouve pour la BoM, et les deux décisions qui bloquent. Les 478 vérifications couvrent les neuf modules, sur des données fictives uniquement.</a:t>
+              <a:t>Trois messages : ce qui est construit, ce que ça prouve pour la BoM, et les deux décisions qui bloquent. Les 579 vérifications couvrent les neuf modules, sur des données fictives uniquement.</a:t>
             </a:r>
             <a:endParaRPr lang="en-US" dirty="0"/>
           </a:p>
@@ -1344,7 +1344,7 @@
           <a:p>
             <a:r>
               <a:rPr lang="en-US" dirty="0"/>
-              <a:t>Les tests tournent avec une seule commande : tests/run_tests.sh. Ils prouvent que le code applique les règles figées, pas que ces règles sont les bonnes pour MIPS. Les deux failles corrigées sont dans la PR #10.</a:t>
+              <a:t>Les tests tournent avec une seule commande : tests/run_tests.sh. Ils prouvent que le code applique les règles figées, pas que ces règles sont les bonnes pour MIPS. Les trois failles corrigées sont dans la PR #10.</a:t>
             </a:r>
             <a:endParaRPr lang="en-US" dirty="0"/>
           </a:p>
@@ -3836,7 +3836,7 @@
                 <a:ea typeface="Cambria" pitchFamily="34" charset="-122"/>
                 <a:cs typeface="Cambria" pitchFamily="34" charset="-120"/>
               </a:rPr>
-              <a:t>478</a:t>
+              <a:t>579</a:t>
             </a:r>
             <a:endParaRPr lang="en-US" sz="5400" dirty="0"/>
           </a:p>
@@ -3886,7 +3886,7 @@
                   <a:schemeClr val="tx2"/>
                 </a:solidFill>
               </a:rPr>
-              <a:t>sur 8 suites</a:t>
+              <a:t>sur 10 suites</a:t>
             </a:r>
             <a:endParaRPr lang="en-US" sz="1400" dirty="0"/>
           </a:p>
@@ -12647,7 +12647,7 @@
                   <a:schemeClr val="tx1"/>
                 </a:solidFill>
               </a:rPr>
-              <a:t>478 vérifications automatiques ont déjà corrigé deux failles</a:t>
+              <a:t>579 vérifications automatiques ont déjà corrigé trois failles</a:t>
             </a:r>
             <a:endParaRPr lang="en-US" sz="3000" dirty="0"/>
           </a:p>
@@ -12679,7 +12679,7 @@
                 <a:gridCol w="2834640"/>
                 <a:gridCol w="1371600"/>
               </a:tblGrid>
-              <a:tr h="411480">
+              <a:tr h="365760">
                 <a:tc>
                   <a:txBody>
                     <a:bodyPr/>
@@ -12803,7 +12803,7 @@
                   </a:tcPr>
                 </a:tc>
               </a:tr>
-              <a:tr h="411480">
+              <a:tr h="365760">
                 <a:tc>
                   <a:txBody>
                     <a:bodyPr/>
@@ -12921,7 +12921,7 @@
                   </a:tcPr>
                 </a:tc>
               </a:tr>
-              <a:tr h="411480">
+              <a:tr h="365760">
                 <a:tc>
                   <a:txBody>
                     <a:bodyPr/>
@@ -13039,7 +13039,125 @@
                   </a:tcPr>
                 </a:tc>
               </a:tr>
-              <a:tr h="411480">
+              <a:tr h="365760">
+                <a:tc>
+                  <a:txBody>
+                    <a:bodyPr/>
+                    <a:lstStyle/>
+                    <a:p>
+                      <a:pPr indent="0" marL="0">
+                        <a:buNone/>
+                      </a:pPr>
+                      <a:r>
+                        <a:rPr lang="en-US" sz="1300" dirty="0">
+                          <a:solidFill>
+                            <a:schemeClr val="tx1"/>
+                          </a:solidFill>
+                        </a:rPr>
+                        <a:t>Approbation KYC</a:t>
+                      </a:r>
+                      <a:endParaRPr lang="en-US" sz="1300" dirty="0"/>
+                    </a:p>
+                  </a:txBody>
+                  <a:tcPr marL="54864" marR="54864" marT="54864" marB="54864" anchor="ctr">
+                    <a:lnL w="6350" cap="flat" cmpd="sng" algn="ctr">
+                      <a:solidFill>
+                        <a:srgbClr val="D5DDE7"/>
+                      </a:solidFill>
+                      <a:prstDash val="solid"/>
+                      <a:round/>
+                      <a:headEnd type="none" w="med" len="med"/>
+                      <a:tailEnd type="none" w="med" len="med"/>
+                    </a:lnL>
+                    <a:lnR w="6350" cap="flat" cmpd="sng" algn="ctr">
+                      <a:solidFill>
+                        <a:srgbClr val="D5DDE7"/>
+                      </a:solidFill>
+                      <a:prstDash val="solid"/>
+                      <a:round/>
+                      <a:headEnd type="none" w="med" len="med"/>
+                      <a:tailEnd type="none" w="med" len="med"/>
+                    </a:lnR>
+                    <a:lnT w="6350" cap="flat" cmpd="sng" algn="ctr">
+                      <a:solidFill>
+                        <a:srgbClr val="D5DDE7"/>
+                      </a:solidFill>
+                      <a:prstDash val="solid"/>
+                      <a:round/>
+                      <a:headEnd type="none" w="med" len="med"/>
+                      <a:tailEnd type="none" w="med" len="med"/>
+                    </a:lnT>
+                    <a:lnB w="6350" cap="flat" cmpd="sng" algn="ctr">
+                      <a:solidFill>
+                        <a:srgbClr val="D5DDE7"/>
+                      </a:solidFill>
+                      <a:prstDash val="solid"/>
+                      <a:round/>
+                      <a:headEnd type="none" w="med" len="med"/>
+                      <a:tailEnd type="none" w="med" len="med"/>
+                    </a:lnB>
+                  </a:tcPr>
+                </a:tc>
+                <a:tc>
+                  <a:txBody>
+                    <a:bodyPr/>
+                    <a:lstStyle/>
+                    <a:p>
+                      <a:pPr algn="r" indent="0" marL="0">
+                        <a:buNone/>
+                      </a:pPr>
+                      <a:r>
+                        <a:rPr lang="en-US" sz="1300" dirty="0">
+                          <a:solidFill>
+                            <a:schemeClr val="tx1"/>
+                          </a:solidFill>
+                        </a:rPr>
+                        <a:t>78</a:t>
+                      </a:r>
+                      <a:endParaRPr lang="en-US" sz="1300" dirty="0"/>
+                    </a:p>
+                  </a:txBody>
+                  <a:tcPr marL="54864" marR="54864" marT="54864" marB="54864" anchor="ctr">
+                    <a:lnL w="6350" cap="flat" cmpd="sng" algn="ctr">
+                      <a:solidFill>
+                        <a:srgbClr val="D5DDE7"/>
+                      </a:solidFill>
+                      <a:prstDash val="solid"/>
+                      <a:round/>
+                      <a:headEnd type="none" w="med" len="med"/>
+                      <a:tailEnd type="none" w="med" len="med"/>
+                    </a:lnL>
+                    <a:lnR w="6350" cap="flat" cmpd="sng" algn="ctr">
+                      <a:solidFill>
+                        <a:srgbClr val="D5DDE7"/>
+                      </a:solidFill>
+                      <a:prstDash val="solid"/>
+                      <a:round/>
+                      <a:headEnd type="none" w="med" len="med"/>
+                      <a:tailEnd type="none" w="med" len="med"/>
+                    </a:lnR>
+                    <a:lnT w="6350" cap="flat" cmpd="sng" algn="ctr">
+                      <a:solidFill>
+                        <a:srgbClr val="D5DDE7"/>
+                      </a:solidFill>
+                      <a:prstDash val="solid"/>
+                      <a:round/>
+                      <a:headEnd type="none" w="med" len="med"/>
+                      <a:tailEnd type="none" w="med" len="med"/>
+                    </a:lnT>
+                    <a:lnB w="6350" cap="flat" cmpd="sng" algn="ctr">
+                      <a:solidFill>
+                        <a:srgbClr val="D5DDE7"/>
+                      </a:solidFill>
+                      <a:prstDash val="solid"/>
+                      <a:round/>
+                      <a:headEnd type="none" w="med" len="med"/>
+                      <a:tailEnd type="none" w="med" len="med"/>
+                    </a:lnB>
+                  </a:tcPr>
+                </a:tc>
+              </a:tr>
+              <a:tr h="365760">
                 <a:tc>
                   <a:txBody>
                     <a:bodyPr/>
@@ -13157,7 +13275,7 @@
                   </a:tcPr>
                 </a:tc>
               </a:tr>
-              <a:tr h="411480">
+              <a:tr h="365760">
                 <a:tc>
                   <a:txBody>
                     <a:bodyPr/>
@@ -13275,7 +13393,7 @@
                   </a:tcPr>
                 </a:tc>
               </a:tr>
-              <a:tr h="411480">
+              <a:tr h="365760">
                 <a:tc>
                   <a:txBody>
                     <a:bodyPr/>
@@ -13393,7 +13511,7 @@
                   </a:tcPr>
                 </a:tc>
               </a:tr>
-              <a:tr h="411480">
+              <a:tr h="365760">
                 <a:tc>
                   <a:txBody>
                     <a:bodyPr/>
@@ -13511,7 +13629,7 @@
                   </a:tcPr>
                 </a:tc>
               </a:tr>
-              <a:tr h="411480">
+              <a:tr h="365760">
                 <a:tc>
                   <a:txBody>
                     <a:bodyPr/>
@@ -13629,7 +13747,125 @@
                   </a:tcPr>
                 </a:tc>
               </a:tr>
-              <a:tr h="411480">
+              <a:tr h="365760">
+                <a:tc>
+                  <a:txBody>
+                    <a:bodyPr/>
+                    <a:lstStyle/>
+                    <a:p>
+                      <a:pPr indent="0" marL="0">
+                        <a:buNone/>
+                      </a:pPr>
+                      <a:r>
+                        <a:rPr lang="en-US" sz="1300" dirty="0">
+                          <a:solidFill>
+                            <a:schemeClr val="tx1"/>
+                          </a:solidFill>
+                        </a:rPr>
+                        <a:t>2FA obligatoire</a:t>
+                      </a:r>
+                      <a:endParaRPr lang="en-US" sz="1300" dirty="0"/>
+                    </a:p>
+                  </a:txBody>
+                  <a:tcPr marL="54864" marR="54864" marT="54864" marB="54864" anchor="ctr">
+                    <a:lnL w="6350" cap="flat" cmpd="sng" algn="ctr">
+                      <a:solidFill>
+                        <a:srgbClr val="D5DDE7"/>
+                      </a:solidFill>
+                      <a:prstDash val="solid"/>
+                      <a:round/>
+                      <a:headEnd type="none" w="med" len="med"/>
+                      <a:tailEnd type="none" w="med" len="med"/>
+                    </a:lnL>
+                    <a:lnR w="6350" cap="flat" cmpd="sng" algn="ctr">
+                      <a:solidFill>
+                        <a:srgbClr val="D5DDE7"/>
+                      </a:solidFill>
+                      <a:prstDash val="solid"/>
+                      <a:round/>
+                      <a:headEnd type="none" w="med" len="med"/>
+                      <a:tailEnd type="none" w="med" len="med"/>
+                    </a:lnR>
+                    <a:lnT w="6350" cap="flat" cmpd="sng" algn="ctr">
+                      <a:solidFill>
+                        <a:srgbClr val="D5DDE7"/>
+                      </a:solidFill>
+                      <a:prstDash val="solid"/>
+                      <a:round/>
+                      <a:headEnd type="none" w="med" len="med"/>
+                      <a:tailEnd type="none" w="med" len="med"/>
+                    </a:lnT>
+                    <a:lnB w="6350" cap="flat" cmpd="sng" algn="ctr">
+                      <a:solidFill>
+                        <a:srgbClr val="D5DDE7"/>
+                      </a:solidFill>
+                      <a:prstDash val="solid"/>
+                      <a:round/>
+                      <a:headEnd type="none" w="med" len="med"/>
+                      <a:tailEnd type="none" w="med" len="med"/>
+                    </a:lnB>
+                  </a:tcPr>
+                </a:tc>
+                <a:tc>
+                  <a:txBody>
+                    <a:bodyPr/>
+                    <a:lstStyle/>
+                    <a:p>
+                      <a:pPr algn="r" indent="0" marL="0">
+                        <a:buNone/>
+                      </a:pPr>
+                      <a:r>
+                        <a:rPr lang="en-US" sz="1300" dirty="0">
+                          <a:solidFill>
+                            <a:schemeClr val="tx1"/>
+                          </a:solidFill>
+                        </a:rPr>
+                        <a:t>23</a:t>
+                      </a:r>
+                      <a:endParaRPr lang="en-US" sz="1300" dirty="0"/>
+                    </a:p>
+                  </a:txBody>
+                  <a:tcPr marL="54864" marR="54864" marT="54864" marB="54864" anchor="ctr">
+                    <a:lnL w="6350" cap="flat" cmpd="sng" algn="ctr">
+                      <a:solidFill>
+                        <a:srgbClr val="D5DDE7"/>
+                      </a:solidFill>
+                      <a:prstDash val="solid"/>
+                      <a:round/>
+                      <a:headEnd type="none" w="med" len="med"/>
+                      <a:tailEnd type="none" w="med" len="med"/>
+                    </a:lnL>
+                    <a:lnR w="6350" cap="flat" cmpd="sng" algn="ctr">
+                      <a:solidFill>
+                        <a:srgbClr val="D5DDE7"/>
+                      </a:solidFill>
+                      <a:prstDash val="solid"/>
+                      <a:round/>
+                      <a:headEnd type="none" w="med" len="med"/>
+                      <a:tailEnd type="none" w="med" len="med"/>
+                    </a:lnR>
+                    <a:lnT w="6350" cap="flat" cmpd="sng" algn="ctr">
+                      <a:solidFill>
+                        <a:srgbClr val="D5DDE7"/>
+                      </a:solidFill>
+                      <a:prstDash val="solid"/>
+                      <a:round/>
+                      <a:headEnd type="none" w="med" len="med"/>
+                      <a:tailEnd type="none" w="med" len="med"/>
+                    </a:lnT>
+                    <a:lnB w="6350" cap="flat" cmpd="sng" algn="ctr">
+                      <a:solidFill>
+                        <a:srgbClr val="D5DDE7"/>
+                      </a:solidFill>
+                      <a:prstDash val="solid"/>
+                      <a:round/>
+                      <a:headEnd type="none" w="med" len="med"/>
+                      <a:tailEnd type="none" w="med" len="med"/>
+                    </a:lnB>
+                  </a:tcPr>
+                </a:tc>
+              </a:tr>
+              <a:tr h="365760">
                 <a:tc>
                   <a:txBody>
                     <a:bodyPr/>
@@ -13759,8 +13995,8 @@
         </p:nvSpPr>
         <p:spPr>
           <a:xfrm>
-            <a:off x="457200" y="5074920"/>
-            <a:ext cx="4206240" cy="731520"/>
+            <a:off x="457200" y="5440680"/>
+            <a:ext cx="4206240" cy="640080"/>
           </a:xfrm>
           <a:prstGeom prst="rect">
             <a:avLst/>
@@ -13781,7 +14017,7 @@
                   <a:schemeClr val="tx2"/>
                 </a:solidFill>
               </a:rPr>
-              <a:t>Données fictives, montants attendus calculés à la main. Sept erreurs volontaires dans le code : toutes détectées.</a:t>
+              <a:t>Données fictives, montants attendus calculés à la main. Treize erreurs volontaires dans le code : toutes détectées.</a:t>
             </a:r>
             <a:endParaRPr lang="en-US" sz="1200" dirty="0"/>
           </a:p>
@@ -13796,11 +14032,11 @@
         <p:spPr>
           <a:xfrm>
             <a:off x="5120640" y="1234440"/>
-            <a:ext cx="6583680" cy="1325880"/>
+            <a:ext cx="6583680" cy="1078992"/>
           </a:xfrm>
           <a:prstGeom prst="roundRect">
             <a:avLst>
-              <a:gd name="adj" fmla="val 5517"/>
+              <a:gd name="adj" fmla="val 6780"/>
             </a:avLst>
           </a:prstGeom>
           <a:solidFill>
@@ -13883,8 +14119,8 @@
         </p:nvSpPr>
         <p:spPr>
           <a:xfrm>
-            <a:off x="5715000" y="1764792"/>
-            <a:ext cx="5852160" cy="731520"/>
+            <a:off x="5715000" y="1709928"/>
+            <a:ext cx="5852160" cy="566928"/>
           </a:xfrm>
           <a:prstGeom prst="rect">
             <a:avLst/>
@@ -13900,14 +14136,14 @@
               <a:buNone/>
             </a:pPr>
             <a:r>
-              <a:rPr lang="en-US" sz="1300" dirty="0">
+              <a:rPr lang="en-US" sz="1200" dirty="0">
                 <a:solidFill>
                   <a:schemeClr val="tx2"/>
                 </a:solidFill>
               </a:rPr>
               <a:t>Cinq échecs depuis une adresse bloquaient tout le bureau. Désormais par compte ; une adresse seulement au-delà de 50 échecs.</a:t>
             </a:r>
-            <a:endParaRPr lang="en-US" sz="1300" dirty="0"/>
+            <a:endParaRPr lang="en-US" sz="1200" dirty="0"/>
           </a:p>
         </p:txBody>
       </p:sp>
@@ -13919,12 +14155,12 @@
         </p:nvSpPr>
         <p:spPr>
           <a:xfrm>
-            <a:off x="5120640" y="2743200"/>
-            <a:ext cx="6583680" cy="1325880"/>
+            <a:off x="5120640" y="2423160"/>
+            <a:ext cx="6583680" cy="1078992"/>
           </a:xfrm>
           <a:prstGeom prst="roundRect">
             <a:avLst>
-              <a:gd name="adj" fmla="val 5517"/>
+              <a:gd name="adj" fmla="val 6780"/>
             </a:avLst>
           </a:prstGeom>
           <a:solidFill>
@@ -13946,7 +14182,7 @@
         </p:nvSpPr>
         <p:spPr>
           <a:xfrm>
-            <a:off x="5303520" y="2926080"/>
+            <a:off x="5303520" y="2606040"/>
             <a:ext cx="274320" cy="274320"/>
           </a:xfrm>
           <a:prstGeom prst="ellipse">
@@ -13971,7 +14207,7 @@
         </p:nvSpPr>
         <p:spPr>
           <a:xfrm>
-            <a:off x="5715000" y="2834640"/>
+            <a:off x="5715000" y="2514600"/>
             <a:ext cx="5852160" cy="411480"/>
           </a:xfrm>
           <a:prstGeom prst="rect">
@@ -14007,8 +14243,8 @@
         </p:nvSpPr>
         <p:spPr>
           <a:xfrm>
-            <a:off x="5715000" y="3273552"/>
-            <a:ext cx="5852160" cy="731520"/>
+            <a:off x="5715000" y="2898648"/>
+            <a:ext cx="5852160" cy="566928"/>
           </a:xfrm>
           <a:prstGeom prst="rect">
             <a:avLst/>
@@ -14024,14 +14260,14 @@
               <a:buNone/>
             </a:pPr>
             <a:r>
-              <a:rPr lang="en-US" sz="1300" dirty="0">
+              <a:rPr lang="en-US" sz="1200" dirty="0">
                 <a:solidFill>
                   <a:schemeClr val="tx2"/>
                 </a:solidFill>
               </a:rPr>
               <a:t>Deux changements dans la même seconde laissaient une session ouverte. Heure enregistrée à la microseconde.</a:t>
             </a:r>
-            <a:endParaRPr lang="en-US" sz="1300" dirty="0"/>
+            <a:endParaRPr lang="en-US" sz="1200" dirty="0"/>
           </a:p>
         </p:txBody>
       </p:sp>
@@ -14043,12 +14279,12 @@
         </p:nvSpPr>
         <p:spPr>
           <a:xfrm>
-            <a:off x="5120640" y="4251960"/>
-            <a:ext cx="6583680" cy="1325880"/>
+            <a:off x="5120640" y="3611880"/>
+            <a:ext cx="6583680" cy="1078992"/>
           </a:xfrm>
           <a:prstGeom prst="roundRect">
             <a:avLst>
-              <a:gd name="adj" fmla="val 5517"/>
+              <a:gd name="adj" fmla="val 6780"/>
             </a:avLst>
           </a:prstGeom>
           <a:solidFill>
@@ -14070,7 +14306,131 @@
         </p:nvSpPr>
         <p:spPr>
           <a:xfrm>
-            <a:off x="5303520" y="4434840"/>
+            <a:off x="5303520" y="3794760"/>
+            <a:ext cx="274320" cy="274320"/>
+          </a:xfrm>
+          <a:prstGeom prst="ellipse">
+            <a:avLst/>
+          </a:prstGeom>
+          <a:solidFill>
+            <a:schemeClr val="accent4"/>
+          </a:solidFill>
+          <a:ln w="12700">
+            <a:solidFill>
+              <a:schemeClr val="accent4"/>
+            </a:solidFill>
+            <a:prstDash val="solid"/>
+          </a:ln>
+        </p:spPr>
+      </p:sp>
+      <p:sp>
+        <p:nvSpPr>
+          <p:cNvPr id="15" name="Text 12"/>
+          <p:cNvSpPr txBox="1"/>
+          <p:nvPr/>
+        </p:nvSpPr>
+        <p:spPr>
+          <a:xfrm>
+            <a:off x="5715000" y="3703320"/>
+            <a:ext cx="5852160" cy="411480"/>
+          </a:xfrm>
+          <a:prstGeom prst="rect">
+            <a:avLst/>
+          </a:prstGeom>
+          <a:noFill/>
+          <a:ln/>
+        </p:spPr>
+        <p:txBody>
+          <a:bodyPr wrap="square" lIns="0" tIns="0" rIns="0" bIns="0" rtlCol="0" anchor="ctr"/>
+          <a:lstStyle/>
+          <a:p>
+            <a:pPr algn="l" indent="0" marL="0">
+              <a:buNone/>
+            </a:pPr>
+            <a:r>
+              <a:rPr lang="en-US" sz="1600" b="1" dirty="0">
+                <a:solidFill>
+                  <a:schemeClr val="tx1"/>
+                </a:solidFill>
+              </a:rPr>
+              <a:t>Double regard sur l'approbation KYC</a:t>
+            </a:r>
+            <a:endParaRPr lang="en-US" sz="1600" dirty="0"/>
+          </a:p>
+        </p:txBody>
+      </p:sp>
+      <p:sp>
+        <p:nvSpPr>
+          <p:cNvPr id="16" name="Text 13"/>
+          <p:cNvSpPr txBox="1"/>
+          <p:nvPr/>
+        </p:nvSpPr>
+        <p:spPr>
+          <a:xfrm>
+            <a:off x="5715000" y="4087368"/>
+            <a:ext cx="5852160" cy="566928"/>
+          </a:xfrm>
+          <a:prstGeom prst="rect">
+            <a:avLst/>
+          </a:prstGeom>
+          <a:noFill/>
+          <a:ln/>
+        </p:spPr>
+        <p:txBody>
+          <a:bodyPr wrap="square" lIns="0" tIns="0" rIns="0" bIns="0" rtlCol="0" anchor="t"/>
+          <a:lstStyle/>
+          <a:p>
+            <a:pPr algn="l" indent="0" marL="0">
+              <a:buNone/>
+            </a:pPr>
+            <a:r>
+              <a:rPr lang="en-US" sz="1200" dirty="0">
+                <a:solidFill>
+                  <a:schemeClr val="tx2"/>
+                </a:solidFill>
+              </a:rPr>
+              <a:t>Un analyste approbateur pouvait réassigner le dossier puis le trancher. Désormais exclu, comme tout ce qui a eu la main sur le dossier.</a:t>
+            </a:r>
+            <a:endParaRPr lang="en-US" sz="1200" dirty="0"/>
+          </a:p>
+        </p:txBody>
+      </p:sp>
+      <p:sp>
+        <p:nvSpPr>
+          <p:cNvPr id="17" name="fix-3"/>
+          <p:cNvSpPr/>
+          <p:nvPr/>
+        </p:nvSpPr>
+        <p:spPr>
+          <a:xfrm>
+            <a:off x="5120640" y="4800600"/>
+            <a:ext cx="6583680" cy="1078992"/>
+          </a:xfrm>
+          <a:prstGeom prst="roundRect">
+            <a:avLst>
+              <a:gd name="adj" fmla="val 6780"/>
+            </a:avLst>
+          </a:prstGeom>
+          <a:solidFill>
+            <a:schemeClr val="bg2"/>
+          </a:solidFill>
+          <a:ln w="9525">
+            <a:solidFill>
+              <a:schemeClr val="bg2"/>
+            </a:solidFill>
+            <a:prstDash val="solid"/>
+          </a:ln>
+        </p:spPr>
+      </p:sp>
+      <p:sp>
+        <p:nvSpPr>
+          <p:cNvPr id="18" name="fixdot-3"/>
+          <p:cNvSpPr/>
+          <p:nvPr/>
+        </p:nvSpPr>
+        <p:spPr>
+          <a:xfrm>
+            <a:off x="5303520" y="4983480"/>
             <a:ext cx="274320" cy="274320"/>
           </a:xfrm>
           <a:prstGeom prst="ellipse">
@@ -14089,13 +14449,13 @@
       </p:sp>
       <p:sp>
         <p:nvSpPr>
-          <p:cNvPr id="15" name="Text 12"/>
+          <p:cNvPr id="19" name="Text 16"/>
           <p:cNvSpPr txBox="1"/>
           <p:nvPr/>
         </p:nvSpPr>
         <p:spPr>
           <a:xfrm>
-            <a:off x="5715000" y="4343400"/>
+            <a:off x="5715000" y="4892040"/>
             <a:ext cx="5852160" cy="411480"/>
           </a:xfrm>
           <a:prstGeom prst="rect">
@@ -14125,14 +14485,14 @@
       </p:sp>
       <p:sp>
         <p:nvSpPr>
-          <p:cNvPr id="16" name="Text 13"/>
+          <p:cNvPr id="20" name="Text 17"/>
           <p:cNvSpPr txBox="1"/>
           <p:nvPr/>
         </p:nvSpPr>
         <p:spPr>
           <a:xfrm>
-            <a:off x="5715000" y="4782312"/>
-            <a:ext cx="5852160" cy="731520"/>
+            <a:off x="5715000" y="5276088"/>
+            <a:ext cx="5852160" cy="566928"/>
           </a:xfrm>
           <a:prstGeom prst="rect">
             <a:avLst/>
@@ -14148,14 +14508,14 @@
               <a:buNone/>
             </a:pPr>
             <a:r>
-              <a:rPr lang="en-US" sz="1300" dirty="0">
+              <a:rPr lang="en-US" sz="1200" dirty="0">
                 <a:solidFill>
                   <a:schemeClr val="tx2"/>
                 </a:solidFill>
               </a:rPr>
-              <a:t>Les règles métier (unité, remboursements, TVA), le vrai BigQuery, un vrai mois MCB, la 2FA obligatoire, les écrans.</a:t>
-            </a:r>
-            <a:endParaRPr lang="en-US" sz="1300" dirty="0"/>
+              <a:t>Les règles métier (unité, remboursements, TVA), le vrai BigQuery, un vrai mois MCB, les écrans.</a:t>
+            </a:r>
+            <a:endParaRPr lang="en-US" sz="1200" dirty="0"/>
           </a:p>
         </p:txBody>
       </p:sp>

</xml_diff>

<commit_message>
French recap (docx, pptx): approval step states the stricter four-eyes rule
The merchant journey (diagram, table, slide and notes) still said
'approver other than the analyst'; it now says the approver never
handled the case (not its creator, analyst or reassigner).

Co-Authored-By: Claude Opus 5.5 <noreply@anthropic.com>
Claude-Session: https://claude.ai/code/session_01ALCBMQrSwdEMnX9x1hQAFX
</commit_message>
<xml_diff>
--- a/outputs/recap/MIPS-recapitulatif.pptx
+++ b/outputs/recap/MIPS-recapitulatif.pptx
@@ -117,31 +117,31 @@
   <p:extLst>
     <p:ext uri="{521415D9-36F7-43E2-AB2F-B90AF26B5E84}">
       <p14:sectionLst xmlns:p14="http://schemas.microsoft.com/office/powerpoint/2010/main">
-        <p14:section name="Introduction" id="{3d84282c-dd2e-e9be-fce3-e9d442f89700}">
+        <p14:section name="Introduction" id="{ea42540a-c17e-cc72-c85c-39a4905a33fe}">
           <p14:sldIdLst>
             <p14:sldId id="256"/>
             <p14:sldId id="257"/>
           </p14:sldIdLst>
         </p14:section>
-        <p14:section name="La plateforme" id="{efb57f8e-6cc1-8ff7-3425-58634588c188}">
+        <p14:section name="La plateforme" id="{47b96006-777e-941f-e4db-681f27bb3edf}">
           <p14:sldIdLst>
             <p14:sldId id="258"/>
             <p14:sldId id="259"/>
             <p14:sldId id="260"/>
           </p14:sldIdLst>
         </p14:section>
-        <p14:section name="Fonds et BoM" id="{c1743b85-26b9-d5be-33fa-3179219594b7}">
+        <p14:section name="Fonds et BoM" id="{6092009d-8b0a-963c-8e26-9deb64fabcc8}">
           <p14:sldIdLst>
             <p14:sldId id="261"/>
             <p14:sldId id="262"/>
           </p14:sldIdLst>
         </p14:section>
-        <p14:section name="Qualité" id="{1e843aba-b6d4-83a7-4911-0cb724480f3c}">
+        <p14:section name="Qualité" id="{3f87fbf7-500d-969d-da01-abc5edbb9b7f}">
           <p14:sldIdLst>
             <p14:sldId id="263"/>
           </p14:sldIdLst>
         </p14:section>
-        <p14:section name="Suite" id="{4c63805f-e60b-f9da-d56f-b0b9b6b880cf}">
+        <p14:section name="Suite" id="{10476a33-35f4-e651-31f3-d1355738cd51}">
           <p14:sldIdLst>
             <p14:sldId id="264"/>
             <p14:sldId id="265"/>
@@ -992,7 +992,7 @@
           <a:p>
             <a:r>
               <a:rPr lang="en-US" dirty="0"/>
-              <a:t>Les gardes : sans double authentification, puis sans conditions acceptées, le marchand ne peut rien faire. L'approbation finale exige un approbateur différent de l'analyste et zéro blocage.</a:t>
+              <a:t>Les gardes : sans double authentification, puis sans conditions acceptées, le marchand ne peut rien faire. L'approbation finale exige zéro blocage et un approbateur qui n'a jamais eu la main sur le dossier : ni créateur, ni analyste, ni auteur d'une réassignation.</a:t>
             </a:r>
             <a:endParaRPr lang="en-US" dirty="0"/>
           </a:p>
@@ -7489,7 +7489,7 @@
                   <a:schemeClr val="tx2"/>
                 </a:solidFill>
               </a:rPr>
-              <a:t>approbateur ≠ analyste</a:t>
+              <a:t>approbateur jamais intervenu</a:t>
             </a:r>
             <a:endParaRPr lang="en-US" sz="1200" dirty="0"/>
           </a:p>
@@ -14389,7 +14389,7 @@
                   <a:schemeClr val="tx2"/>
                 </a:solidFill>
               </a:rPr>
-              <a:t>Un analyste approbateur pouvait réassigner le dossier puis le trancher. Désormais exclu, comme tout ce qui a eu la main sur le dossier.</a:t>
+              <a:t>Un analyste approbateur pouvait réassigner le dossier puis le trancher. Désormais exclu, comme toute personne qui a eu la main sur le dossier.</a:t>
             </a:r>
             <a:endParaRPr lang="en-US" sz="1200" dirty="0"/>
           </a:p>

</xml_diff>

<commit_message>
French recap (docx, pptx): 590 checks with the ClamAV antivirus suite
Eleven suites, fourteen deliberate faults detected, the antivirus
detection rate listed as not proven (test signature only), and the
antivirus decision now names ClamAV with clamd and freshclam.

Co-Authored-By: Claude Opus 5.5 <noreply@anthropic.com>
Claude-Session: https://claude.ai/code/session_01ALCBMQrSwdEMnX9x1hQAFX
</commit_message>
<xml_diff>
--- a/outputs/recap/MIPS-recapitulatif.pptx
+++ b/outputs/recap/MIPS-recapitulatif.pptx
@@ -117,31 +117,31 @@
   <p:extLst>
     <p:ext uri="{521415D9-36F7-43E2-AB2F-B90AF26B5E84}">
       <p14:sectionLst xmlns:p14="http://schemas.microsoft.com/office/powerpoint/2010/main">
-        <p14:section name="Introduction" id="{ea42540a-c17e-cc72-c85c-39a4905a33fe}">
+        <p14:section name="Introduction" id="{f406b6dc-029e-7d15-b28b-05e2d28c40b6}">
           <p14:sldIdLst>
             <p14:sldId id="256"/>
             <p14:sldId id="257"/>
           </p14:sldIdLst>
         </p14:section>
-        <p14:section name="La plateforme" id="{47b96006-777e-941f-e4db-681f27bb3edf}">
+        <p14:section name="La plateforme" id="{b60a7fe0-6543-5ab1-662f-13e62c995edd}">
           <p14:sldIdLst>
             <p14:sldId id="258"/>
             <p14:sldId id="259"/>
             <p14:sldId id="260"/>
           </p14:sldIdLst>
         </p14:section>
-        <p14:section name="Fonds et BoM" id="{6092009d-8b0a-963c-8e26-9deb64fabcc8}">
+        <p14:section name="Fonds et BoM" id="{8d519305-f7ae-2b13-5808-9da5bacf0675}">
           <p14:sldIdLst>
             <p14:sldId id="261"/>
             <p14:sldId id="262"/>
           </p14:sldIdLst>
         </p14:section>
-        <p14:section name="Qualité" id="{3f87fbf7-500d-969d-da01-abc5edbb9b7f}">
+        <p14:section name="Qualité" id="{4bf0b732-b88b-a775-2d30-e0d975572fce}">
           <p14:sldIdLst>
             <p14:sldId id="263"/>
           </p14:sldIdLst>
         </p14:section>
-        <p14:section name="Suite" id="{10476a33-35f4-e651-31f3-d1355738cd51}">
+        <p14:section name="Suite" id="{9810867f-eb63-77f8-3068-c691a6357b74}">
           <p14:sldIdLst>
             <p14:sldId id="264"/>
             <p14:sldId id="265"/>
@@ -816,7 +816,7 @@
           <a:p>
             <a:r>
               <a:rPr lang="en-US" dirty="0"/>
-              <a:t>Trois messages : ce qui est construit, ce que ça prouve pour la BoM, et les deux décisions qui bloquent. Les 579 vérifications couvrent les neuf modules, sur des données fictives uniquement.</a:t>
+              <a:t>Trois messages : ce qui est construit, ce que ça prouve pour la BoM, et les deux décisions qui bloquent. Les 590 vérifications couvrent les neuf modules, sur des données fictives uniquement.</a:t>
             </a:r>
             <a:endParaRPr lang="en-US" dirty="0"/>
           </a:p>
@@ -3836,7 +3836,7 @@
                 <a:ea typeface="Cambria" pitchFamily="34" charset="-122"/>
                 <a:cs typeface="Cambria" pitchFamily="34" charset="-120"/>
               </a:rPr>
-              <a:t>579</a:t>
+              <a:t>590</a:t>
             </a:r>
             <a:endParaRPr lang="en-US" sz="5400" dirty="0"/>
           </a:p>
@@ -3886,7 +3886,7 @@
                   <a:schemeClr val="tx2"/>
                 </a:solidFill>
               </a:rPr>
-              <a:t>sur 10 suites</a:t>
+              <a:t>sur 11 suites</a:t>
             </a:r>
             <a:endParaRPr lang="en-US" sz="1400" dirty="0"/>
           </a:p>
@@ -12647,7 +12647,7 @@
                   <a:schemeClr val="tx1"/>
                 </a:solidFill>
               </a:rPr>
-              <a:t>579 vérifications automatiques ont déjà corrigé trois failles</a:t>
+              <a:t>590 vérifications automatiques ont déjà corrigé trois failles</a:t>
             </a:r>
             <a:endParaRPr lang="en-US" sz="3000" dirty="0"/>
           </a:p>
@@ -12679,7 +12679,7 @@
                 <a:gridCol w="2834640"/>
                 <a:gridCol w="1371600"/>
               </a:tblGrid>
-              <a:tr h="365760">
+              <a:tr h="338328">
                 <a:tc>
                   <a:txBody>
                     <a:bodyPr/>
@@ -12803,7 +12803,7 @@
                   </a:tcPr>
                 </a:tc>
               </a:tr>
-              <a:tr h="365760">
+              <a:tr h="338328">
                 <a:tc>
                   <a:txBody>
                     <a:bodyPr/>
@@ -12921,7 +12921,7 @@
                   </a:tcPr>
                 </a:tc>
               </a:tr>
-              <a:tr h="365760">
+              <a:tr h="338328">
                 <a:tc>
                   <a:txBody>
                     <a:bodyPr/>
@@ -13039,7 +13039,7 @@
                   </a:tcPr>
                 </a:tc>
               </a:tr>
-              <a:tr h="365760">
+              <a:tr h="338328">
                 <a:tc>
                   <a:txBody>
                     <a:bodyPr/>
@@ -13157,7 +13157,7 @@
                   </a:tcPr>
                 </a:tc>
               </a:tr>
-              <a:tr h="365760">
+              <a:tr h="338328">
                 <a:tc>
                   <a:txBody>
                     <a:bodyPr/>
@@ -13275,7 +13275,7 @@
                   </a:tcPr>
                 </a:tc>
               </a:tr>
-              <a:tr h="365760">
+              <a:tr h="338328">
                 <a:tc>
                   <a:txBody>
                     <a:bodyPr/>
@@ -13393,7 +13393,7 @@
                   </a:tcPr>
                 </a:tc>
               </a:tr>
-              <a:tr h="365760">
+              <a:tr h="338328">
                 <a:tc>
                   <a:txBody>
                     <a:bodyPr/>
@@ -13511,7 +13511,7 @@
                   </a:tcPr>
                 </a:tc>
               </a:tr>
-              <a:tr h="365760">
+              <a:tr h="338328">
                 <a:tc>
                   <a:txBody>
                     <a:bodyPr/>
@@ -13629,7 +13629,7 @@
                   </a:tcPr>
                 </a:tc>
               </a:tr>
-              <a:tr h="365760">
+              <a:tr h="338328">
                 <a:tc>
                   <a:txBody>
                     <a:bodyPr/>
@@ -13747,7 +13747,125 @@
                   </a:tcPr>
                 </a:tc>
               </a:tr>
-              <a:tr h="365760">
+              <a:tr h="338328">
+                <a:tc>
+                  <a:txBody>
+                    <a:bodyPr/>
+                    <a:lstStyle/>
+                    <a:p>
+                      <a:pPr indent="0" marL="0">
+                        <a:buNone/>
+                      </a:pPr>
+                      <a:r>
+                        <a:rPr lang="en-US" sz="1300" dirty="0">
+                          <a:solidFill>
+                            <a:schemeClr val="tx1"/>
+                          </a:solidFill>
+                        </a:rPr>
+                        <a:t>Antivirus (ClamAV)</a:t>
+                      </a:r>
+                      <a:endParaRPr lang="en-US" sz="1300" dirty="0"/>
+                    </a:p>
+                  </a:txBody>
+                  <a:tcPr marL="54864" marR="54864" marT="54864" marB="54864" anchor="ctr">
+                    <a:lnL w="6350" cap="flat" cmpd="sng" algn="ctr">
+                      <a:solidFill>
+                        <a:srgbClr val="D5DDE7"/>
+                      </a:solidFill>
+                      <a:prstDash val="solid"/>
+                      <a:round/>
+                      <a:headEnd type="none" w="med" len="med"/>
+                      <a:tailEnd type="none" w="med" len="med"/>
+                    </a:lnL>
+                    <a:lnR w="6350" cap="flat" cmpd="sng" algn="ctr">
+                      <a:solidFill>
+                        <a:srgbClr val="D5DDE7"/>
+                      </a:solidFill>
+                      <a:prstDash val="solid"/>
+                      <a:round/>
+                      <a:headEnd type="none" w="med" len="med"/>
+                      <a:tailEnd type="none" w="med" len="med"/>
+                    </a:lnR>
+                    <a:lnT w="6350" cap="flat" cmpd="sng" algn="ctr">
+                      <a:solidFill>
+                        <a:srgbClr val="D5DDE7"/>
+                      </a:solidFill>
+                      <a:prstDash val="solid"/>
+                      <a:round/>
+                      <a:headEnd type="none" w="med" len="med"/>
+                      <a:tailEnd type="none" w="med" len="med"/>
+                    </a:lnT>
+                    <a:lnB w="6350" cap="flat" cmpd="sng" algn="ctr">
+                      <a:solidFill>
+                        <a:srgbClr val="D5DDE7"/>
+                      </a:solidFill>
+                      <a:prstDash val="solid"/>
+                      <a:round/>
+                      <a:headEnd type="none" w="med" len="med"/>
+                      <a:tailEnd type="none" w="med" len="med"/>
+                    </a:lnB>
+                  </a:tcPr>
+                </a:tc>
+                <a:tc>
+                  <a:txBody>
+                    <a:bodyPr/>
+                    <a:lstStyle/>
+                    <a:p>
+                      <a:pPr algn="r" indent="0" marL="0">
+                        <a:buNone/>
+                      </a:pPr>
+                      <a:r>
+                        <a:rPr lang="en-US" sz="1300" dirty="0">
+                          <a:solidFill>
+                            <a:schemeClr val="tx1"/>
+                          </a:solidFill>
+                        </a:rPr>
+                        <a:t>11</a:t>
+                      </a:r>
+                      <a:endParaRPr lang="en-US" sz="1300" dirty="0"/>
+                    </a:p>
+                  </a:txBody>
+                  <a:tcPr marL="54864" marR="54864" marT="54864" marB="54864" anchor="ctr">
+                    <a:lnL w="6350" cap="flat" cmpd="sng" algn="ctr">
+                      <a:solidFill>
+                        <a:srgbClr val="D5DDE7"/>
+                      </a:solidFill>
+                      <a:prstDash val="solid"/>
+                      <a:round/>
+                      <a:headEnd type="none" w="med" len="med"/>
+                      <a:tailEnd type="none" w="med" len="med"/>
+                    </a:lnL>
+                    <a:lnR w="6350" cap="flat" cmpd="sng" algn="ctr">
+                      <a:solidFill>
+                        <a:srgbClr val="D5DDE7"/>
+                      </a:solidFill>
+                      <a:prstDash val="solid"/>
+                      <a:round/>
+                      <a:headEnd type="none" w="med" len="med"/>
+                      <a:tailEnd type="none" w="med" len="med"/>
+                    </a:lnR>
+                    <a:lnT w="6350" cap="flat" cmpd="sng" algn="ctr">
+                      <a:solidFill>
+                        <a:srgbClr val="D5DDE7"/>
+                      </a:solidFill>
+                      <a:prstDash val="solid"/>
+                      <a:round/>
+                      <a:headEnd type="none" w="med" len="med"/>
+                      <a:tailEnd type="none" w="med" len="med"/>
+                    </a:lnT>
+                    <a:lnB w="6350" cap="flat" cmpd="sng" algn="ctr">
+                      <a:solidFill>
+                        <a:srgbClr val="D5DDE7"/>
+                      </a:solidFill>
+                      <a:prstDash val="solid"/>
+                      <a:round/>
+                      <a:headEnd type="none" w="med" len="med"/>
+                      <a:tailEnd type="none" w="med" len="med"/>
+                    </a:lnB>
+                  </a:tcPr>
+                </a:tc>
+              </a:tr>
+              <a:tr h="338328">
                 <a:tc>
                   <a:txBody>
                     <a:bodyPr/>
@@ -13865,7 +13983,7 @@
                   </a:tcPr>
                 </a:tc>
               </a:tr>
-              <a:tr h="365760">
+              <a:tr h="338328">
                 <a:tc>
                   <a:txBody>
                     <a:bodyPr/>
@@ -14017,7 +14135,7 @@
                   <a:schemeClr val="tx2"/>
                 </a:solidFill>
               </a:rPr>
-              <a:t>Données fictives, montants attendus calculés à la main. Treize erreurs volontaires dans le code : toutes détectées.</a:t>
+              <a:t>Données fictives, montants attendus calculés à la main. Quatorze erreurs volontaires dans le code : toutes détectées.</a:t>
             </a:r>
             <a:endParaRPr lang="en-US" sz="1200" dirty="0"/>
           </a:p>
@@ -14513,7 +14631,7 @@
                   <a:schemeClr val="tx2"/>
                 </a:solidFill>
               </a:rPr>
-              <a:t>Les règles métier (unité, remboursements, TVA), le vrai BigQuery, un vrai mois MCB, les écrans.</a:t>
+              <a:t>Les règles métier (unité, remboursements, TVA), le vrai BigQuery, un vrai mois MCB, le taux de détection de l'antivirus (signature de test), les écrans.</a:t>
             </a:r>
             <a:endParaRPr lang="en-US" sz="1200" dirty="0"/>
           </a:p>

</xml_diff>

<commit_message>
French recap (docx, pptx): S04d recaptured with ClamAV
The BoM evidence table no longer says 'not scanned': S04d now shows
'antivirus OK' with the official signatures, active on the demo only.
The untested items explain why a refused infected file could not be
shown, and the antivirus decision gives the measured clamd vs clamscan
times.

Co-Authored-By: Claude Opus 5.5 <noreply@anthropic.com>
Claude-Session: https://claude.ai/code/session_01ALCBMQrSwdEMnX9x1hQAFX
</commit_message>
<xml_diff>
--- a/outputs/recap/MIPS-recapitulatif.pptx
+++ b/outputs/recap/MIPS-recapitulatif.pptx
@@ -117,31 +117,31 @@
   <p:extLst>
     <p:ext uri="{521415D9-36F7-43E2-AB2F-B90AF26B5E84}">
       <p14:sectionLst xmlns:p14="http://schemas.microsoft.com/office/powerpoint/2010/main">
-        <p14:section name="Introduction" id="{f406b6dc-029e-7d15-b28b-05e2d28c40b6}">
+        <p14:section name="Introduction" id="{68695024-1b3a-f354-d3cc-40bc48821380}">
           <p14:sldIdLst>
             <p14:sldId id="256"/>
             <p14:sldId id="257"/>
           </p14:sldIdLst>
         </p14:section>
-        <p14:section name="La plateforme" id="{b60a7fe0-6543-5ab1-662f-13e62c995edd}">
+        <p14:section name="La plateforme" id="{f7340988-bdd8-8008-aebf-8928e0f8609f}">
           <p14:sldIdLst>
             <p14:sldId id="258"/>
             <p14:sldId id="259"/>
             <p14:sldId id="260"/>
           </p14:sldIdLst>
         </p14:section>
-        <p14:section name="Fonds et BoM" id="{8d519305-f7ae-2b13-5808-9da5bacf0675}">
+        <p14:section name="Fonds et BoM" id="{b46bf6d5-ac0c-9d8d-cd5b-17b0f8ab4b22}">
           <p14:sldIdLst>
             <p14:sldId id="261"/>
             <p14:sldId id="262"/>
           </p14:sldIdLst>
         </p14:section>
-        <p14:section name="Qualité" id="{4bf0b732-b88b-a775-2d30-e0d975572fce}">
+        <p14:section name="Qualité" id="{f65b3982-0bbb-2b0d-a1ae-12b8aaaec13e}">
           <p14:sldIdLst>
             <p14:sldId id="263"/>
           </p14:sldIdLst>
         </p14:section>
-        <p14:section name="Suite" id="{9810867f-eb63-77f8-3068-c691a6357b74}">
+        <p14:section name="Suite" id="{a16613b4-8639-5eab-6340-947f0353945c}">
           <p14:sldIdLst>
             <p14:sldId id="264"/>
             <p14:sldId id="265"/>
@@ -1256,7 +1256,7 @@
           <a:p>
             <a:r>
               <a:rPr lang="en-US" dirty="0"/>
-              <a:t>Les captures prouvent que les fonctions sont construites, pas qu'elles sont en service. S01f et C05 montrent un texte de conditions de remplissage.</a:t>
+              <a:t>S04d a été recapturée le 30 octobre avec ClamAV et les signatures officielles : chaque pièce affiche « antivirus OK », ce qui veut dire « aucune signature connue détectée ». Les captures prouvent que les fonctions sont construites, pas qu'elles sont en service. S01f et C05 montrent un texte de conditions de remplissage.</a:t>
             </a:r>
             <a:endParaRPr lang="en-US" dirty="0"/>
           </a:p>
@@ -11290,7 +11290,7 @@
                             <a:schemeClr val="tx1"/>
                           </a:solidFill>
                         </a:rPr>
-                        <a:t>Pas d'antivirus : pièces « not scanned »</a:t>
+                        <a:t>Antivirus actif sur la démo seulement (S04d)</a:t>
                       </a:r>
                       <a:endParaRPr lang="en-US" sz="1300" dirty="0"/>
                     </a:p>

</xml_diff>